<commit_message>
docs(pitch): pass 2, the README, deck and pitch documents match main
What works today now lists Sentinel's alerts and autofreeze, the Solana
Actions, the whole-story e2e test, the security CI job and the indexer's
snapshot as done; Telegram on a real phone, the web app's owner actions,
the devnet run and the recordings stay in progress. 911 tests (783
TypeScript, 128 Rust). The demo script gains the Blink path for approving
and freezing, with the tunnel and the owner's devnet wallet, and keeps the
terminal fallbacks. Deck rebuilt (pptx and PDF).

Co-Authored-By: Claude Opus 5.5 <noreply@anthropic.com>
Claude-Session: https://claude.ai/code/session_01Dip2hRKComRMwhMYq5YdYL
</commit_message>
<xml_diff>
--- a/docs/pitch/leash-deck.pptx
+++ b/docs/pitch/leash-deck.pptx
@@ -778,7 +778,7 @@
           <a:p>
             <a:r>
               <a:rPr lang="en-US" dirty="0"/>
-              <a:t>We keep building through Colosseum. The order is: finish the owner's side, make every alert actionable from a link, and only then go to mainnet, after an audit.</a:t>
+              <a:t>We keep building through Colosseum. The order is: finish the owner's side in the web app, put the wallet one tap from every alert, and only then go to mainnet, after an audit.</a:t>
             </a:r>
             <a:endParaRPr lang="en-US" dirty="0"/>
           </a:p>
@@ -1307,7 +1307,7 @@
             <a:r>
               <a:rPr lang="en-US" dirty="0"/>
               <a:t>The agent reads a buying guide with a hidden instruction: tip twenty-five dollars to a stranger. In this run we script the agent to fall for it, and the screen says so, because we want to show what happens when the model is fooled. It tries three times: three blocks, three strikes, and the agent freezes itself, on-chain. The model was fooled. The money wasn't moved.
-If something fails live: approve with the web app or pnpm owner:approve; unfreeze with the web app or pnpm owner:unfreeze (it also clears leftover strikes). Run the 'Before each take' checklist in apps/agent-demo/README.md before every take.</a:t>
+If something fails live: approve from the Blink in the owner's wallet, the web app or pnpm owner:approve; unfreeze with the web app or pnpm owner:unfreeze (it also clears leftover strikes). Run the 'Before each take' checklist in apps/agent-demo/README.md before every take.</a:t>
             </a:r>
             <a:endParaRPr lang="en-US" dirty="0"/>
           </a:p>
@@ -4331,7 +4331,7 @@
                 <a:ea typeface="Arial" pitchFamily="34" charset="-122"/>
                 <a:cs typeface="Arial" pitchFamily="34" charset="-120"/>
               </a:rPr>
-              <a:t>The demo on devnet</a:t>
+              <a:t>The demo on devnet, and its recording</a:t>
             </a:r>
             <a:endParaRPr lang="en-US" sz="1150" dirty="0"/>
           </a:p>
@@ -4373,7 +4373,7 @@
                 <a:ea typeface="Arial" pitchFamily="34" charset="-122"/>
                 <a:cs typeface="Arial" pitchFamily="34" charset="-120"/>
               </a:rPr>
-              <a:t>Telegram alerts</a:t>
+              <a:t>Telegram alerts checked on a real phone</a:t>
             </a:r>
             <a:endParaRPr lang="en-US" sz="1150" dirty="0"/>
           </a:p>
@@ -4514,28 +4514,7 @@
                 <a:ea typeface="Arial" pitchFamily="34" charset="-122"/>
                 <a:cs typeface="Arial" pitchFamily="34" charset="-120"/>
               </a:rPr>
-              <a:t>Solana Action links to freeze or approve from anywhere</a:t>
-            </a:r>
-            <a:endParaRPr lang="en-US" sz="1150" dirty="0"/>
-          </a:p>
-          <a:p>
-            <a:pPr marL="177800" indent="-177800">
-              <a:spcAft>
-                <a:spcPts val="600"/>
-              </a:spcAft>
-              <a:buSzPct val="100000"/>
-              <a:buChar char="•"/>
-            </a:pPr>
-            <a:r>
-              <a:rPr lang="en-US" sz="1150" dirty="0">
-                <a:solidFill>
-                  <a:srgbClr val="0F1419"/>
-                </a:solidFill>
-                <a:latin typeface="Arial" pitchFamily="34" charset="0"/>
-                <a:ea typeface="Arial" pitchFamily="34" charset="-122"/>
-                <a:cs typeface="Arial" pitchFamily="34" charset="-120"/>
-              </a:rPr>
-              <a:t>The guardian freezes an agent by itself when Sentinel sees an attack</a:t>
+              <a:t>Telegram buttons that open the owner's wallet directly</a:t>
             </a:r>
             <a:endParaRPr lang="en-US" sz="1150" dirty="0"/>
           </a:p>
@@ -11003,7 +10982,7 @@
         </p:blipFill>
         <p:spPr>
           <a:xfrm>
-            <a:off x="548640" y="1499616"/>
+            <a:off x="548640" y="1481328"/>
             <a:ext cx="201168" cy="201168"/>
           </a:xfrm>
           <a:prstGeom prst="rect">
@@ -11019,8 +10998,8 @@
         </p:nvSpPr>
         <p:spPr>
           <a:xfrm>
-            <a:off x="868680" y="1481328"/>
-            <a:ext cx="4480560" cy="274320"/>
+            <a:off x="868680" y="1463040"/>
+            <a:ext cx="4663440" cy="246888"/>
           </a:xfrm>
           <a:prstGeom prst="rect">
             <a:avLst/>
@@ -11066,7 +11045,7 @@
         </p:blipFill>
         <p:spPr>
           <a:xfrm>
-            <a:off x="548640" y="1883664"/>
+            <a:off x="548640" y="1801368"/>
             <a:ext cx="201168" cy="201168"/>
           </a:xfrm>
           <a:prstGeom prst="rect">
@@ -11082,8 +11061,8 @@
         </p:nvSpPr>
         <p:spPr>
           <a:xfrm>
-            <a:off x="868680" y="1865376"/>
-            <a:ext cx="4480560" cy="548640"/>
+            <a:off x="868680" y="1783080"/>
+            <a:ext cx="4663440" cy="246888"/>
           </a:xfrm>
           <a:prstGeom prst="rect">
             <a:avLst/>
@@ -11107,7 +11086,7 @@
                 <a:ea typeface="Arial" pitchFamily="34" charset="-122"/>
                 <a:cs typeface="Arial" pitchFamily="34" charset="-120"/>
               </a:rPr>
-              <a:t>60 policy test cases give the same result in TypeScript, in Rust, and in LiteSVM on the exact program binary deployed on devnet (checked byte for byte)</a:t>
+              <a:t>60 policy cases agree in TypeScript, in Rust and on the deployed binary</a:t>
             </a:r>
             <a:endParaRPr lang="en-US" sz="1150" dirty="0"/>
           </a:p>
@@ -11129,7 +11108,7 @@
         </p:blipFill>
         <p:spPr>
           <a:xfrm>
-            <a:off x="548640" y="2542032"/>
+            <a:off x="548640" y="2121408"/>
             <a:ext cx="201168" cy="201168"/>
           </a:xfrm>
           <a:prstGeom prst="rect">
@@ -11145,8 +11124,8 @@
         </p:nvSpPr>
         <p:spPr>
           <a:xfrm>
-            <a:off x="868680" y="2523744"/>
-            <a:ext cx="4480560" cy="274320"/>
+            <a:off x="868680" y="2103120"/>
+            <a:ext cx="4663440" cy="246888"/>
           </a:xfrm>
           <a:prstGeom prst="rect">
             <a:avLst/>
@@ -11192,7 +11171,7 @@
         </p:blipFill>
         <p:spPr>
           <a:xfrm>
-            <a:off x="548640" y="2926080"/>
+            <a:off x="548640" y="2441448"/>
             <a:ext cx="201168" cy="201168"/>
           </a:xfrm>
           <a:prstGeom prst="rect">
@@ -11208,8 +11187,8 @@
         </p:nvSpPr>
         <p:spPr>
           <a:xfrm>
-            <a:off x="868680" y="2907792"/>
-            <a:ext cx="4480560" cy="274320"/>
+            <a:off x="868680" y="2423160"/>
+            <a:ext cx="4663440" cy="246888"/>
           </a:xfrm>
           <a:prstGeom prst="rect">
             <a:avLst/>
@@ -11255,7 +11234,7 @@
         </p:blipFill>
         <p:spPr>
           <a:xfrm>
-            <a:off x="548640" y="3310128"/>
+            <a:off x="548640" y="2761488"/>
             <a:ext cx="201168" cy="201168"/>
           </a:xfrm>
           <a:prstGeom prst="rect">
@@ -11271,8 +11250,8 @@
         </p:nvSpPr>
         <p:spPr>
           <a:xfrm>
-            <a:off x="868680" y="3291840"/>
-            <a:ext cx="4480560" cy="274320"/>
+            <a:off x="868680" y="2743200"/>
+            <a:ext cx="4663440" cy="246888"/>
           </a:xfrm>
           <a:prstGeom prst="rect">
             <a:avLst/>
@@ -11296,7 +11275,7 @@
                 <a:ea typeface="Arial" pitchFamily="34" charset="-122"/>
                 <a:cs typeface="Arial" pitchFamily="34" charset="-120"/>
               </a:rPr>
-              <a:t>The whole demo story, end to end on a local Solana validator</a:t>
+              <a:t>The whole story: on a local validator, and in one test on every commit</a:t>
             </a:r>
             <a:endParaRPr lang="en-US" sz="1150" dirty="0"/>
           </a:p>
@@ -11318,7 +11297,7 @@
         </p:blipFill>
         <p:spPr>
           <a:xfrm>
-            <a:off x="548640" y="3694176"/>
+            <a:off x="548640" y="3081528"/>
             <a:ext cx="201168" cy="201168"/>
           </a:xfrm>
           <a:prstGeom prst="rect">
@@ -11334,8 +11313,8 @@
         </p:nvSpPr>
         <p:spPr>
           <a:xfrm>
-            <a:off x="868680" y="3675888"/>
-            <a:ext cx="4480560" cy="274320"/>
+            <a:off x="868680" y="3063240"/>
+            <a:ext cx="4663440" cy="246888"/>
           </a:xfrm>
           <a:prstGeom prst="rect">
             <a:avLst/>
@@ -11364,32 +11343,10 @@
             <a:endParaRPr lang="en-US" sz="1150" dirty="0"/>
           </a:p>
         </p:txBody>
-      </p:sp>
-      <p:sp>
-        <p:nvSpPr>
-          <p:cNvPr id="20" name="Shape 11"/>
-          <p:cNvSpPr/>
-          <p:nvPr/>
-        </p:nvSpPr>
-        <p:spPr>
-          <a:xfrm>
-            <a:off x="5669280" y="1051560"/>
-            <a:ext cx="1325880" cy="292608"/>
-          </a:xfrm>
-          <a:prstGeom prst="roundRect">
-            <a:avLst>
-              <a:gd name="adj" fmla="val 312500"/>
-            </a:avLst>
-          </a:prstGeom>
-          <a:solidFill>
-            <a:srgbClr val="F8EEE6"/>
-          </a:solidFill>
-          <a:ln/>
-        </p:spPr>
       </p:sp>
       <p:pic>
         <p:nvPicPr>
-          <p:cNvPr id="21" name="Image 7" descr="preencoded.png">    </p:cNvPr>
+          <p:cNvPr id="20" name="Image 7" descr="preencoded.png">    </p:cNvPr>
           <p:cNvPicPr>
             <a:picLocks noChangeAspect="1"/>
           </p:cNvPicPr>
@@ -11403,8 +11360,8 @@
         </p:blipFill>
         <p:spPr>
           <a:xfrm>
-            <a:off x="5762915" y="1115934"/>
-            <a:ext cx="163860" cy="163860"/>
+            <a:off x="548640" y="3401568"/>
+            <a:ext cx="201168" cy="201168"/>
           </a:xfrm>
           <a:prstGeom prst="rect">
             <a:avLst/>
@@ -11413,46 +11370,46 @@
       </p:pic>
       <p:sp>
         <p:nvSpPr>
-          <p:cNvPr id="22" name="Text 12"/>
-          <p:cNvSpPr txBox="1"/>
-          <p:nvPr/>
-        </p:nvSpPr>
-        <p:spPr>
-          <a:xfrm>
-            <a:off x="5981639" y="1051560"/>
-            <a:ext cx="958657" cy="292608"/>
-          </a:xfrm>
-          <a:prstGeom prst="rect">
-            <a:avLst/>
-          </a:prstGeom>
-          <a:noFill/>
-          <a:ln/>
-        </p:spPr>
-        <p:txBody>
-          <a:bodyPr wrap="square" lIns="0" tIns="0" rIns="0" bIns="0" rtlCol="0" anchor="ctr"/>
+          <p:cNvPr id="21" name="Text 11"/>
+          <p:cNvSpPr txBox="1"/>
+          <p:nvPr/>
+        </p:nvSpPr>
+        <p:spPr>
+          <a:xfrm>
+            <a:off x="868680" y="3383280"/>
+            <a:ext cx="4663440" cy="246888"/>
+          </a:xfrm>
+          <a:prstGeom prst="rect">
+            <a:avLst/>
+          </a:prstGeom>
+          <a:noFill/>
+          <a:ln/>
+        </p:spPr>
+        <p:txBody>
+          <a:bodyPr wrap="square" lIns="0" tIns="0" rIns="0" bIns="0" rtlCol="0" anchor="t"/>
           <a:lstStyle/>
           <a:p>
             <a:pPr algn="l" indent="0" marL="0">
               <a:buNone/>
             </a:pPr>
             <a:r>
-              <a:rPr lang="en-US" sz="1050" b="1" dirty="0">
-                <a:solidFill>
-                  <a:srgbClr val="B45309"/>
-                </a:solidFill>
-                <a:latin typeface="Arial" pitchFamily="34" charset="0"/>
-                <a:ea typeface="Arial" pitchFamily="34" charset="-122"/>
-                <a:cs typeface="Arial" pitchFamily="34" charset="-120"/>
-              </a:rPr>
-              <a:t>In progress</a:t>
-            </a:r>
-            <a:endParaRPr lang="en-US" sz="1050" dirty="0"/>
+              <a:rPr lang="en-US" sz="1150" dirty="0">
+                <a:solidFill>
+                  <a:srgbClr val="0F1419"/>
+                </a:solidFill>
+                <a:latin typeface="Arial" pitchFamily="34" charset="0"/>
+                <a:ea typeface="Arial" pitchFamily="34" charset="-122"/>
+                <a:cs typeface="Arial" pitchFamily="34" charset="-120"/>
+              </a:rPr>
+              <a:t>Sentinel's alerts, and the guardian's autofreeze</a:t>
+            </a:r>
+            <a:endParaRPr lang="en-US" sz="1150" dirty="0"/>
           </a:p>
         </p:txBody>
       </p:sp>
       <p:pic>
         <p:nvPicPr>
-          <p:cNvPr id="23" name="Image 8" descr="preencoded.png">    </p:cNvPr>
+          <p:cNvPr id="22" name="Image 8" descr="preencoded.png">    </p:cNvPr>
           <p:cNvPicPr>
             <a:picLocks noChangeAspect="1"/>
           </p:cNvPicPr>
@@ -11466,8 +11423,8 @@
         </p:blipFill>
         <p:spPr>
           <a:xfrm>
-            <a:off x="5669280" y="1499616"/>
-            <a:ext cx="182880" cy="182880"/>
+            <a:off x="548640" y="3721608"/>
+            <a:ext cx="201168" cy="201168"/>
           </a:xfrm>
           <a:prstGeom prst="rect">
             <a:avLst/>
@@ -11476,14 +11433,14 @@
       </p:pic>
       <p:sp>
         <p:nvSpPr>
-          <p:cNvPr id="24" name="Text 13"/>
-          <p:cNvSpPr txBox="1"/>
-          <p:nvPr/>
-        </p:nvSpPr>
-        <p:spPr>
-          <a:xfrm>
-            <a:off x="5961888" y="1481328"/>
-            <a:ext cx="2606040" cy="384048"/>
+          <p:cNvPr id="23" name="Text 12"/>
+          <p:cNvSpPr txBox="1"/>
+          <p:nvPr/>
+        </p:nvSpPr>
+        <p:spPr>
+          <a:xfrm>
+            <a:off x="868680" y="3703320"/>
+            <a:ext cx="4663440" cy="246888"/>
           </a:xfrm>
           <a:prstGeom prst="rect">
             <a:avLst/>
@@ -11507,7 +11464,7 @@
                 <a:ea typeface="Arial" pitchFamily="34" charset="-122"/>
                 <a:cs typeface="Arial" pitchFamily="34" charset="-120"/>
               </a:rPr>
-              <a:t>Pairing, approve, freeze and unfreeze in the web app</a:t>
+              <a:t>Solana Actions (Blinks): approve or freeze from a link</a:t>
             </a:r>
             <a:endParaRPr lang="en-US" sz="1150" dirty="0"/>
           </a:p>
@@ -11515,7 +11472,7 @@
       </p:sp>
       <p:pic>
         <p:nvPicPr>
-          <p:cNvPr id="25" name="Image 9" descr="preencoded.png">    </p:cNvPr>
+          <p:cNvPr id="24" name="Image 9" descr="preencoded.png">    </p:cNvPr>
           <p:cNvPicPr>
             <a:picLocks noChangeAspect="1"/>
           </p:cNvPicPr>
@@ -11529,8 +11486,8 @@
         </p:blipFill>
         <p:spPr>
           <a:xfrm>
-            <a:off x="5669280" y="2011680"/>
-            <a:ext cx="182880" cy="182880"/>
+            <a:off x="548640" y="4041648"/>
+            <a:ext cx="201168" cy="201168"/>
           </a:xfrm>
           <a:prstGeom prst="rect">
             <a:avLst/>
@@ -11539,14 +11496,14 @@
       </p:pic>
       <p:sp>
         <p:nvSpPr>
-          <p:cNvPr id="26" name="Text 14"/>
-          <p:cNvSpPr txBox="1"/>
-          <p:nvPr/>
-        </p:nvSpPr>
-        <p:spPr>
-          <a:xfrm>
-            <a:off x="5961888" y="1993392"/>
-            <a:ext cx="2606040" cy="201168"/>
+          <p:cNvPr id="25" name="Text 13"/>
+          <p:cNvSpPr txBox="1"/>
+          <p:nvPr/>
+        </p:nvSpPr>
+        <p:spPr>
+          <a:xfrm>
+            <a:off x="868680" y="4023360"/>
+            <a:ext cx="4663440" cy="246888"/>
           </a:xfrm>
           <a:prstGeom prst="rect">
             <a:avLst/>
@@ -11570,11 +11527,33 @@
                 <a:ea typeface="Arial" pitchFamily="34" charset="-122"/>
                 <a:cs typeface="Arial" pitchFamily="34" charset="-120"/>
               </a:rPr>
-              <a:t>Telegram alerts</a:t>
+              <a:t>A security CI job runs the invariant tests by name</a:t>
             </a:r>
             <a:endParaRPr lang="en-US" sz="1150" dirty="0"/>
           </a:p>
         </p:txBody>
+      </p:sp>
+      <p:sp>
+        <p:nvSpPr>
+          <p:cNvPr id="26" name="Shape 14"/>
+          <p:cNvSpPr/>
+          <p:nvPr/>
+        </p:nvSpPr>
+        <p:spPr>
+          <a:xfrm>
+            <a:off x="5669280" y="1051560"/>
+            <a:ext cx="1325880" cy="292608"/>
+          </a:xfrm>
+          <a:prstGeom prst="roundRect">
+            <a:avLst>
+              <a:gd name="adj" fmla="val 312500"/>
+            </a:avLst>
+          </a:prstGeom>
+          <a:solidFill>
+            <a:srgbClr val="F8EEE6"/>
+          </a:solidFill>
+          <a:ln/>
+        </p:spPr>
       </p:sp>
       <p:pic>
         <p:nvPicPr>
@@ -11592,7 +11571,70 @@
         </p:blipFill>
         <p:spPr>
           <a:xfrm>
-            <a:off x="5669280" y="2340864"/>
+            <a:off x="5762915" y="1115934"/>
+            <a:ext cx="163860" cy="163860"/>
+          </a:xfrm>
+          <a:prstGeom prst="rect">
+            <a:avLst/>
+          </a:prstGeom>
+        </p:spPr>
+      </p:pic>
+      <p:sp>
+        <p:nvSpPr>
+          <p:cNvPr id="28" name="Text 15"/>
+          <p:cNvSpPr txBox="1"/>
+          <p:nvPr/>
+        </p:nvSpPr>
+        <p:spPr>
+          <a:xfrm>
+            <a:off x="5981639" y="1051560"/>
+            <a:ext cx="958657" cy="292608"/>
+          </a:xfrm>
+          <a:prstGeom prst="rect">
+            <a:avLst/>
+          </a:prstGeom>
+          <a:noFill/>
+          <a:ln/>
+        </p:spPr>
+        <p:txBody>
+          <a:bodyPr wrap="square" lIns="0" tIns="0" rIns="0" bIns="0" rtlCol="0" anchor="ctr"/>
+          <a:lstStyle/>
+          <a:p>
+            <a:pPr algn="l" indent="0" marL="0">
+              <a:buNone/>
+            </a:pPr>
+            <a:r>
+              <a:rPr lang="en-US" sz="1050" b="1" dirty="0">
+                <a:solidFill>
+                  <a:srgbClr val="B45309"/>
+                </a:solidFill>
+                <a:latin typeface="Arial" pitchFamily="34" charset="0"/>
+                <a:ea typeface="Arial" pitchFamily="34" charset="-122"/>
+                <a:cs typeface="Arial" pitchFamily="34" charset="-120"/>
+              </a:rPr>
+              <a:t>In progress</a:t>
+            </a:r>
+            <a:endParaRPr lang="en-US" sz="1050" dirty="0"/>
+          </a:p>
+        </p:txBody>
+      </p:sp>
+      <p:pic>
+        <p:nvPicPr>
+          <p:cNvPr id="29" name="Image 11" descr="preencoded.png">    </p:cNvPr>
+          <p:cNvPicPr>
+            <a:picLocks noChangeAspect="1"/>
+          </p:cNvPicPr>
+          <p:nvPr/>
+        </p:nvPicPr>
+        <p:blipFill>
+          <a:blip r:embed="rId12"/>
+          <a:stretch>
+            <a:fillRect/>
+          </a:stretch>
+        </p:blipFill>
+        <p:spPr>
+          <a:xfrm>
+            <a:off x="5669280" y="1499616"/>
             <a:ext cx="182880" cy="182880"/>
           </a:xfrm>
           <a:prstGeom prst="rect">
@@ -11602,13 +11644,13 @@
       </p:pic>
       <p:sp>
         <p:nvSpPr>
-          <p:cNvPr id="28" name="Text 15"/>
-          <p:cNvSpPr txBox="1"/>
-          <p:nvPr/>
-        </p:nvSpPr>
-        <p:spPr>
-          <a:xfrm>
-            <a:off x="5961888" y="2322576"/>
+          <p:cNvPr id="30" name="Text 16"/>
+          <p:cNvSpPr txBox="1"/>
+          <p:nvPr/>
+        </p:nvSpPr>
+        <p:spPr>
+          <a:xfrm>
+            <a:off x="5961888" y="1481328"/>
             <a:ext cx="2606040" cy="384048"/>
           </a:xfrm>
           <a:prstGeom prst="rect">
@@ -11633,15 +11675,141 @@
                 <a:ea typeface="Arial" pitchFamily="34" charset="-122"/>
                 <a:cs typeface="Arial" pitchFamily="34" charset="-120"/>
               </a:rPr>
+              <a:t>Pairing, approve, freeze and unfreeze in the web app</a:t>
+            </a:r>
+            <a:endParaRPr lang="en-US" sz="1150" dirty="0"/>
+          </a:p>
+        </p:txBody>
+      </p:sp>
+      <p:pic>
+        <p:nvPicPr>
+          <p:cNvPr id="31" name="Image 12" descr="preencoded.png">    </p:cNvPr>
+          <p:cNvPicPr>
+            <a:picLocks noChangeAspect="1"/>
+          </p:cNvPicPr>
+          <p:nvPr/>
+        </p:nvPicPr>
+        <p:blipFill>
+          <a:blip r:embed="rId13"/>
+          <a:stretch>
+            <a:fillRect/>
+          </a:stretch>
+        </p:blipFill>
+        <p:spPr>
+          <a:xfrm>
+            <a:off x="5669280" y="2011680"/>
+            <a:ext cx="182880" cy="182880"/>
+          </a:xfrm>
+          <a:prstGeom prst="rect">
+            <a:avLst/>
+          </a:prstGeom>
+        </p:spPr>
+      </p:pic>
+      <p:sp>
+        <p:nvSpPr>
+          <p:cNvPr id="32" name="Text 17"/>
+          <p:cNvSpPr txBox="1"/>
+          <p:nvPr/>
+        </p:nvSpPr>
+        <p:spPr>
+          <a:xfrm>
+            <a:off x="5961888" y="1993392"/>
+            <a:ext cx="2606040" cy="384048"/>
+          </a:xfrm>
+          <a:prstGeom prst="rect">
+            <a:avLst/>
+          </a:prstGeom>
+          <a:noFill/>
+          <a:ln/>
+        </p:spPr>
+        <p:txBody>
+          <a:bodyPr wrap="square" lIns="0" tIns="0" rIns="0" bIns="0" rtlCol="0" anchor="t"/>
+          <a:lstStyle/>
+          <a:p>
+            <a:pPr algn="l" indent="0" marL="0">
+              <a:buNone/>
+            </a:pPr>
+            <a:r>
+              <a:rPr lang="en-US" sz="1150" dirty="0">
+                <a:solidFill>
+                  <a:srgbClr val="0F1419"/>
+                </a:solidFill>
+                <a:latin typeface="Arial" pitchFamily="34" charset="0"/>
+                <a:ea typeface="Arial" pitchFamily="34" charset="-122"/>
+                <a:cs typeface="Arial" pitchFamily="34" charset="-120"/>
+              </a:rPr>
               <a:t>The full demo on devnet, and its recording</a:t>
             </a:r>
             <a:endParaRPr lang="en-US" sz="1150" dirty="0"/>
           </a:p>
         </p:txBody>
       </p:sp>
-      <p:sp>
-        <p:nvSpPr>
-          <p:cNvPr id="29" name="Shape 16"/>
+      <p:pic>
+        <p:nvPicPr>
+          <p:cNvPr id="33" name="Image 13" descr="preencoded.png">    </p:cNvPr>
+          <p:cNvPicPr>
+            <a:picLocks noChangeAspect="1"/>
+          </p:cNvPicPr>
+          <p:nvPr/>
+        </p:nvPicPr>
+        <p:blipFill>
+          <a:blip r:embed="rId14"/>
+          <a:stretch>
+            <a:fillRect/>
+          </a:stretch>
+        </p:blipFill>
+        <p:spPr>
+          <a:xfrm>
+            <a:off x="5669280" y="2523744"/>
+            <a:ext cx="182880" cy="182880"/>
+          </a:xfrm>
+          <a:prstGeom prst="rect">
+            <a:avLst/>
+          </a:prstGeom>
+        </p:spPr>
+      </p:pic>
+      <p:sp>
+        <p:nvSpPr>
+          <p:cNvPr id="34" name="Text 18"/>
+          <p:cNvSpPr txBox="1"/>
+          <p:nvPr/>
+        </p:nvSpPr>
+        <p:spPr>
+          <a:xfrm>
+            <a:off x="5961888" y="2505456"/>
+            <a:ext cx="2606040" cy="384048"/>
+          </a:xfrm>
+          <a:prstGeom prst="rect">
+            <a:avLst/>
+          </a:prstGeom>
+          <a:noFill/>
+          <a:ln/>
+        </p:spPr>
+        <p:txBody>
+          <a:bodyPr wrap="square" lIns="0" tIns="0" rIns="0" bIns="0" rtlCol="0" anchor="t"/>
+          <a:lstStyle/>
+          <a:p>
+            <a:pPr algn="l" indent="0" marL="0">
+              <a:buNone/>
+            </a:pPr>
+            <a:r>
+              <a:rPr lang="en-US" sz="1150" dirty="0">
+                <a:solidFill>
+                  <a:srgbClr val="0F1419"/>
+                </a:solidFill>
+                <a:latin typeface="Arial" pitchFamily="34" charset="0"/>
+                <a:ea typeface="Arial" pitchFamily="34" charset="-122"/>
+                <a:cs typeface="Arial" pitchFamily="34" charset="-120"/>
+              </a:rPr>
+              <a:t>Telegram alerts on a real phone (being checked)</a:t>
+            </a:r>
+            <a:endParaRPr lang="en-US" sz="1150" dirty="0"/>
+          </a:p>
+        </p:txBody>
+      </p:sp>
+      <p:sp>
+        <p:nvSpPr>
+          <p:cNvPr id="35" name="Shape 19"/>
           <p:cNvSpPr/>
           <p:nvPr/>
         </p:nvSpPr>
@@ -11675,7 +11843,7 @@
       </p:sp>
       <p:sp>
         <p:nvSpPr>
-          <p:cNvPr id="30" name="Text 17"/>
+          <p:cNvPr id="36" name="Text 20"/>
           <p:cNvSpPr txBox="1"/>
           <p:nvPr/>
         </p:nvSpPr>
@@ -11706,7 +11874,7 @@
                 <a:ea typeface="Arial" pitchFamily="34" charset="-122"/>
                 <a:cs typeface="Arial" pitchFamily="34" charset="-120"/>
               </a:rPr>
-              <a:t>767</a:t>
+              <a:t>911</a:t>
             </a:r>
             <a:endParaRPr lang="en-US" sz="3600" dirty="0"/>
           </a:p>
@@ -11714,7 +11882,7 @@
       </p:sp>
       <p:sp>
         <p:nvSpPr>
-          <p:cNvPr id="31" name="Text 18"/>
+          <p:cNvPr id="37" name="Text 21"/>
           <p:cNvSpPr txBox="1"/>
           <p:nvPr/>
         </p:nvSpPr>
@@ -11753,7 +11921,7 @@
       </p:sp>
       <p:sp>
         <p:nvSpPr>
-          <p:cNvPr id="32" name="Text 19"/>
+          <p:cNvPr id="38" name="Text 22"/>
           <p:cNvSpPr txBox="1"/>
           <p:nvPr/>
         </p:nvSpPr>
@@ -11784,7 +11952,7 @@
                 <a:ea typeface="Arial" pitchFamily="34" charset="-122"/>
                 <a:cs typeface="Arial" pitchFamily="34" charset="-120"/>
               </a:rPr>
-              <a:t>639 TypeScript · 128 Rust</a:t>
+              <a:t>783 TypeScript · 128 Rust</a:t>
             </a:r>
             <a:endParaRPr lang="en-US" sz="1000" dirty="0"/>
           </a:p>

</xml_diff>

<commit_message>
docs: README, deck and pitch documents match main; MIT license
The web app's owner actions are done; pnpm demo heads Try it; 964 tests
(836 TypeScript, 128 Rust). The demo script approves in the web app and
uses the freeze toggle, with Blinks and the terminal as fallbacks. Deck
rebuilt.

Co-Authored-By: Claude Opus 5.5 <noreply@anthropic.com>
Claude-Session: https://claude.ai/code/session_01LTL2wJB5abAQcdhFPuiv4E
</commit_message>
<xml_diff>
--- a/docs/pitch/leash-deck.pptx
+++ b/docs/pitch/leash-deck.pptx
@@ -778,7 +778,7 @@
           <a:p>
             <a:r>
               <a:rPr lang="en-US" dirty="0"/>
-              <a:t>We keep building through Colosseum. The order is: finish the owner's side in the web app, put the wallet one tap from every alert, and only then go to mainnet, after an audit.</a:t>
+              <a:t>We keep building through Colosseum. The order is: the owner's side on devnet, then put the wallet one tap from every alert, and only then go to mainnet, after an audit.</a:t>
             </a:r>
             <a:endParaRPr lang="en-US" dirty="0"/>
           </a:p>
@@ -1307,7 +1307,7 @@
             <a:r>
               <a:rPr lang="en-US" dirty="0"/>
               <a:t>The agent reads a buying guide with a hidden instruction: tip twenty-five dollars to a stranger. In this run we script the agent to fall for it, and the screen says so, because we want to show what happens when the model is fooled. It tries three times: three blocks, three strikes, and the agent freezes itself, on-chain. The model was fooled. The money wasn't moved.
-If something fails live: approve from the Blink in the owner's wallet, the web app or pnpm owner:approve; unfreeze with the web app or pnpm owner:unfreeze (it also clears leftover strikes). Run the 'Before each take' checklist in apps/agent-demo/README.md before every take.</a:t>
+If something fails live: the owner approves and unfreezes in the web app; if that fails, approve from the Blink in the owner's wallet or with pnpm owner:approve, and unfreeze with pnpm owner:unfreeze (it also clears leftover strikes). Run the 'Before each take' checklist in apps/agent-demo/README.md before every take.</a:t>
             </a:r>
             <a:endParaRPr lang="en-US" dirty="0"/>
           </a:p>
@@ -4352,7 +4352,7 @@
                 <a:ea typeface="Arial" pitchFamily="34" charset="-122"/>
                 <a:cs typeface="Arial" pitchFamily="34" charset="-120"/>
               </a:rPr>
-              <a:t>Pairing, approvals and the off switch in the web app</a:t>
+              <a:t>The web app with a real wallet on devnet</a:t>
             </a:r>
             <a:endParaRPr lang="en-US" sz="1150" dirty="0"/>
           </a:p>
@@ -11275,7 +11275,7 @@
                 <a:ea typeface="Arial" pitchFamily="34" charset="-122"/>
                 <a:cs typeface="Arial" pitchFamily="34" charset="-120"/>
               </a:rPr>
-              <a:t>The whole story: on a local validator, and in one test on every commit</a:t>
+              <a:t>The whole story: on a local validator, in CI, and in one command</a:t>
             </a:r>
             <a:endParaRPr lang="en-US" sz="1150" dirty="0"/>
           </a:p>
@@ -11401,7 +11401,7 @@
                 <a:ea typeface="Arial" pitchFamily="34" charset="-122"/>
                 <a:cs typeface="Arial" pitchFamily="34" charset="-120"/>
               </a:rPr>
-              <a:t>Sentinel's alerts, and the guardian's autofreeze</a:t>
+              <a:t>Pairing, approve, freeze and unfreeze in the web app</a:t>
             </a:r>
             <a:endParaRPr lang="en-US" sz="1150" dirty="0"/>
           </a:p>
@@ -11464,7 +11464,7 @@
                 <a:ea typeface="Arial" pitchFamily="34" charset="-122"/>
                 <a:cs typeface="Arial" pitchFamily="34" charset="-120"/>
               </a:rPr>
-              <a:t>Solana Actions (Blinks): approve or freeze from a link</a:t>
+              <a:t>Sentinel's alerts, and the guardian's autofreeze</a:t>
             </a:r>
             <a:endParaRPr lang="en-US" sz="1150" dirty="0"/>
           </a:p>
@@ -11527,37 +11527,15 @@
                 <a:ea typeface="Arial" pitchFamily="34" charset="-122"/>
                 <a:cs typeface="Arial" pitchFamily="34" charset="-120"/>
               </a:rPr>
-              <a:t>A security CI job runs the invariant tests by name</a:t>
+              <a:t>Solana Actions (Blinks): approve or freeze from a link</a:t>
             </a:r>
             <a:endParaRPr lang="en-US" sz="1150" dirty="0"/>
           </a:p>
         </p:txBody>
-      </p:sp>
-      <p:sp>
-        <p:nvSpPr>
-          <p:cNvPr id="26" name="Shape 14"/>
-          <p:cNvSpPr/>
-          <p:nvPr/>
-        </p:nvSpPr>
-        <p:spPr>
-          <a:xfrm>
-            <a:off x="5669280" y="1051560"/>
-            <a:ext cx="1325880" cy="292608"/>
-          </a:xfrm>
-          <a:prstGeom prst="roundRect">
-            <a:avLst>
-              <a:gd name="adj" fmla="val 312500"/>
-            </a:avLst>
-          </a:prstGeom>
-          <a:solidFill>
-            <a:srgbClr val="F8EEE6"/>
-          </a:solidFill>
-          <a:ln/>
-        </p:spPr>
       </p:sp>
       <p:pic>
         <p:nvPicPr>
-          <p:cNvPr id="27" name="Image 10" descr="preencoded.png">    </p:cNvPr>
+          <p:cNvPr id="26" name="Image 10" descr="preencoded.png">    </p:cNvPr>
           <p:cNvPicPr>
             <a:picLocks noChangeAspect="1"/>
           </p:cNvPicPr>
@@ -11571,8 +11549,8 @@
         </p:blipFill>
         <p:spPr>
           <a:xfrm>
-            <a:off x="5762915" y="1115934"/>
-            <a:ext cx="163860" cy="163860"/>
+            <a:off x="548640" y="4361688"/>
+            <a:ext cx="201168" cy="201168"/>
           </a:xfrm>
           <a:prstGeom prst="rect">
             <a:avLst/>
@@ -11581,42 +11559,64 @@
       </p:pic>
       <p:sp>
         <p:nvSpPr>
-          <p:cNvPr id="28" name="Text 15"/>
-          <p:cNvSpPr txBox="1"/>
-          <p:nvPr/>
-        </p:nvSpPr>
-        <p:spPr>
-          <a:xfrm>
-            <a:off x="5981639" y="1051560"/>
-            <a:ext cx="958657" cy="292608"/>
-          </a:xfrm>
-          <a:prstGeom prst="rect">
-            <a:avLst/>
-          </a:prstGeom>
-          <a:noFill/>
-          <a:ln/>
-        </p:spPr>
-        <p:txBody>
-          <a:bodyPr wrap="square" lIns="0" tIns="0" rIns="0" bIns="0" rtlCol="0" anchor="ctr"/>
+          <p:cNvPr id="27" name="Text 14"/>
+          <p:cNvSpPr txBox="1"/>
+          <p:nvPr/>
+        </p:nvSpPr>
+        <p:spPr>
+          <a:xfrm>
+            <a:off x="868680" y="4343400"/>
+            <a:ext cx="4663440" cy="246888"/>
+          </a:xfrm>
+          <a:prstGeom prst="rect">
+            <a:avLst/>
+          </a:prstGeom>
+          <a:noFill/>
+          <a:ln/>
+        </p:spPr>
+        <p:txBody>
+          <a:bodyPr wrap="square" lIns="0" tIns="0" rIns="0" bIns="0" rtlCol="0" anchor="t"/>
           <a:lstStyle/>
           <a:p>
             <a:pPr algn="l" indent="0" marL="0">
               <a:buNone/>
             </a:pPr>
             <a:r>
-              <a:rPr lang="en-US" sz="1050" b="1" dirty="0">
-                <a:solidFill>
-                  <a:srgbClr val="B45309"/>
-                </a:solidFill>
-                <a:latin typeface="Arial" pitchFamily="34" charset="0"/>
-                <a:ea typeface="Arial" pitchFamily="34" charset="-122"/>
-                <a:cs typeface="Arial" pitchFamily="34" charset="-120"/>
-              </a:rPr>
-              <a:t>In progress</a:t>
-            </a:r>
-            <a:endParaRPr lang="en-US" sz="1050" dirty="0"/>
-          </a:p>
-        </p:txBody>
+              <a:rPr lang="en-US" sz="1150" dirty="0">
+                <a:solidFill>
+                  <a:srgbClr val="0F1419"/>
+                </a:solidFill>
+                <a:latin typeface="Arial" pitchFamily="34" charset="0"/>
+                <a:ea typeface="Arial" pitchFamily="34" charset="-122"/>
+                <a:cs typeface="Arial" pitchFamily="34" charset="-120"/>
+              </a:rPr>
+              <a:t>A security CI job runs the invariant tests by name</a:t>
+            </a:r>
+            <a:endParaRPr lang="en-US" sz="1150" dirty="0"/>
+          </a:p>
+        </p:txBody>
+      </p:sp>
+      <p:sp>
+        <p:nvSpPr>
+          <p:cNvPr id="28" name="Shape 15"/>
+          <p:cNvSpPr/>
+          <p:nvPr/>
+        </p:nvSpPr>
+        <p:spPr>
+          <a:xfrm>
+            <a:off x="5669280" y="1051560"/>
+            <a:ext cx="1325880" cy="292608"/>
+          </a:xfrm>
+          <a:prstGeom prst="roundRect">
+            <a:avLst>
+              <a:gd name="adj" fmla="val 312500"/>
+            </a:avLst>
+          </a:prstGeom>
+          <a:solidFill>
+            <a:srgbClr val="F8EEE6"/>
+          </a:solidFill>
+          <a:ln/>
+        </p:spPr>
       </p:sp>
       <p:pic>
         <p:nvPicPr>
@@ -11634,8 +11634,8 @@
         </p:blipFill>
         <p:spPr>
           <a:xfrm>
-            <a:off x="5669280" y="1499616"/>
-            <a:ext cx="182880" cy="182880"/>
+            <a:off x="5762915" y="1115934"/>
+            <a:ext cx="163860" cy="163860"/>
           </a:xfrm>
           <a:prstGeom prst="rect">
             <a:avLst/>
@@ -11650,34 +11650,34 @@
         </p:nvSpPr>
         <p:spPr>
           <a:xfrm>
-            <a:off x="5961888" y="1481328"/>
-            <a:ext cx="2606040" cy="384048"/>
-          </a:xfrm>
-          <a:prstGeom prst="rect">
-            <a:avLst/>
-          </a:prstGeom>
-          <a:noFill/>
-          <a:ln/>
-        </p:spPr>
-        <p:txBody>
-          <a:bodyPr wrap="square" lIns="0" tIns="0" rIns="0" bIns="0" rtlCol="0" anchor="t"/>
+            <a:off x="5981639" y="1051560"/>
+            <a:ext cx="958657" cy="292608"/>
+          </a:xfrm>
+          <a:prstGeom prst="rect">
+            <a:avLst/>
+          </a:prstGeom>
+          <a:noFill/>
+          <a:ln/>
+        </p:spPr>
+        <p:txBody>
+          <a:bodyPr wrap="square" lIns="0" tIns="0" rIns="0" bIns="0" rtlCol="0" anchor="ctr"/>
           <a:lstStyle/>
           <a:p>
             <a:pPr algn="l" indent="0" marL="0">
               <a:buNone/>
             </a:pPr>
             <a:r>
-              <a:rPr lang="en-US" sz="1150" dirty="0">
-                <a:solidFill>
-                  <a:srgbClr val="0F1419"/>
-                </a:solidFill>
-                <a:latin typeface="Arial" pitchFamily="34" charset="0"/>
-                <a:ea typeface="Arial" pitchFamily="34" charset="-122"/>
-                <a:cs typeface="Arial" pitchFamily="34" charset="-120"/>
-              </a:rPr>
-              <a:t>Pairing, approve, freeze and unfreeze in the web app</a:t>
-            </a:r>
-            <a:endParaRPr lang="en-US" sz="1150" dirty="0"/>
+              <a:rPr lang="en-US" sz="1050" b="1" dirty="0">
+                <a:solidFill>
+                  <a:srgbClr val="B45309"/>
+                </a:solidFill>
+                <a:latin typeface="Arial" pitchFamily="34" charset="0"/>
+                <a:ea typeface="Arial" pitchFamily="34" charset="-122"/>
+                <a:cs typeface="Arial" pitchFamily="34" charset="-120"/>
+              </a:rPr>
+              <a:t>In progress</a:t>
+            </a:r>
+            <a:endParaRPr lang="en-US" sz="1050" dirty="0"/>
           </a:p>
         </p:txBody>
       </p:sp>
@@ -11697,7 +11697,7 @@
         </p:blipFill>
         <p:spPr>
           <a:xfrm>
-            <a:off x="5669280" y="2011680"/>
+            <a:off x="5669280" y="1499616"/>
             <a:ext cx="182880" cy="182880"/>
           </a:xfrm>
           <a:prstGeom prst="rect">
@@ -11713,7 +11713,7 @@
         </p:nvSpPr>
         <p:spPr>
           <a:xfrm>
-            <a:off x="5961888" y="1993392"/>
+            <a:off x="5961888" y="1481328"/>
             <a:ext cx="2606040" cy="384048"/>
           </a:xfrm>
           <a:prstGeom prst="rect">
@@ -11760,7 +11760,7 @@
         </p:blipFill>
         <p:spPr>
           <a:xfrm>
-            <a:off x="5669280" y="2523744"/>
+            <a:off x="5669280" y="2011680"/>
             <a:ext cx="182880" cy="182880"/>
           </a:xfrm>
           <a:prstGeom prst="rect">
@@ -11776,7 +11776,7 @@
         </p:nvSpPr>
         <p:spPr>
           <a:xfrm>
-            <a:off x="5961888" y="2505456"/>
+            <a:off x="5961888" y="1993392"/>
             <a:ext cx="2606040" cy="384048"/>
           </a:xfrm>
           <a:prstGeom prst="rect">
@@ -11874,7 +11874,7 @@
                 <a:ea typeface="Arial" pitchFamily="34" charset="-122"/>
                 <a:cs typeface="Arial" pitchFamily="34" charset="-120"/>
               </a:rPr>
-              <a:t>911</a:t>
+              <a:t>964</a:t>
             </a:r>
             <a:endParaRPr lang="en-US" sz="3600" dirty="0"/>
           </a:p>
@@ -11952,7 +11952,7 @@
                 <a:ea typeface="Arial" pitchFamily="34" charset="-122"/>
                 <a:cs typeface="Arial" pitchFamily="34" charset="-120"/>
               </a:rPr>
-              <a:t>783 TypeScript · 128 Rust</a:t>
+              <a:t>836 TypeScript · 128 Rust</a:t>
             </a:r>
             <a:endParaRPr lang="en-US" sz="1000" dirty="0"/>
           </a:p>

</xml_diff>

<commit_message>
docs: Telegram on a real phone and the first devnet x402 payment, in the README, deck and board
The laptop's reports (20261003-0945, 20261003-1015) confirm two things the
README, the deck and the judge Q&A still called "in progress":
- Sentinel's alerts reached Parth's phone, and on a local validator a burst
  of blocked payments made the guardian freeze all agents.
- The first x402 payment through Leash settled on devnet.

The full devnet run and its recording stay "in progress". The deck's .pptx
and PDF are rebuilt from build-deck.cjs. The board's laptop queue and the
WS2 status follow the same reports; test counts wait for the final pass.

Co-Authored-By: Claude Opus 5.5 <noreply@anthropic.com>
Claude-Session: https://claude.ai/code/session_01HymyG6fb24cdptwyaurt2h
</commit_message>
<xml_diff>
--- a/docs/pitch/leash-deck.pptx
+++ b/docs/pitch/leash-deck.pptx
@@ -4356,27 +4356,6 @@
             </a:r>
             <a:endParaRPr lang="en-US" sz="1150" dirty="0"/>
           </a:p>
-          <a:p>
-            <a:pPr marL="177800" indent="-177800">
-              <a:spcAft>
-                <a:spcPts val="600"/>
-              </a:spcAft>
-              <a:buSzPct val="100000"/>
-              <a:buChar char="•"/>
-            </a:pPr>
-            <a:r>
-              <a:rPr lang="en-US" sz="1150" dirty="0">
-                <a:solidFill>
-                  <a:srgbClr val="0F1419"/>
-                </a:solidFill>
-                <a:latin typeface="Arial" pitchFamily="34" charset="0"/>
-                <a:ea typeface="Arial" pitchFamily="34" charset="-122"/>
-                <a:cs typeface="Arial" pitchFamily="34" charset="-120"/>
-              </a:rPr>
-              <a:t>Telegram alerts checked on a real phone</a:t>
-            </a:r>
-            <a:endParaRPr lang="en-US" sz="1150" dirty="0"/>
-          </a:p>
         </p:txBody>
       </p:sp>
       <p:sp>
@@ -11149,7 +11128,7 @@
                 <a:ea typeface="Arial" pitchFamily="34" charset="-122"/>
                 <a:cs typeface="Arial" pitchFamily="34" charset="-120"/>
               </a:rPr>
-              <a:t>x402 payments through the unmodified official facilitator</a:t>
+              <a:t>x402 payments through the unmodified official facilitator, on devnet too</a:t>
             </a:r>
             <a:endParaRPr lang="en-US" sz="1150" dirty="0"/>
           </a:p>
@@ -11464,7 +11443,7 @@
                 <a:ea typeface="Arial" pitchFamily="34" charset="-122"/>
                 <a:cs typeface="Arial" pitchFamily="34" charset="-120"/>
               </a:rPr>
-              <a:t>Sentinel's alerts, and the guardian's autofreeze</a:t>
+              <a:t>Sentinel's alerts on a real phone, and the guardian's autofreeze</a:t>
             </a:r>
             <a:endParaRPr lang="en-US" sz="1150" dirty="0"/>
           </a:p>
@@ -11744,72 +11723,9 @@
           </a:p>
         </p:txBody>
       </p:sp>
-      <p:pic>
-        <p:nvPicPr>
-          <p:cNvPr id="33" name="Image 13" descr="preencoded.png">    </p:cNvPr>
-          <p:cNvPicPr>
-            <a:picLocks noChangeAspect="1"/>
-          </p:cNvPicPr>
-          <p:nvPr/>
-        </p:nvPicPr>
-        <p:blipFill>
-          <a:blip r:embed="rId14"/>
-          <a:stretch>
-            <a:fillRect/>
-          </a:stretch>
-        </p:blipFill>
-        <p:spPr>
-          <a:xfrm>
-            <a:off x="5669280" y="2011680"/>
-            <a:ext cx="182880" cy="182880"/>
-          </a:xfrm>
-          <a:prstGeom prst="rect">
-            <a:avLst/>
-          </a:prstGeom>
-        </p:spPr>
-      </p:pic>
-      <p:sp>
-        <p:nvSpPr>
-          <p:cNvPr id="34" name="Text 18"/>
-          <p:cNvSpPr txBox="1"/>
-          <p:nvPr/>
-        </p:nvSpPr>
-        <p:spPr>
-          <a:xfrm>
-            <a:off x="5961888" y="1993392"/>
-            <a:ext cx="2606040" cy="384048"/>
-          </a:xfrm>
-          <a:prstGeom prst="rect">
-            <a:avLst/>
-          </a:prstGeom>
-          <a:noFill/>
-          <a:ln/>
-        </p:spPr>
-        <p:txBody>
-          <a:bodyPr wrap="square" lIns="0" tIns="0" rIns="0" bIns="0" rtlCol="0" anchor="t"/>
-          <a:lstStyle/>
-          <a:p>
-            <a:pPr algn="l" indent="0" marL="0">
-              <a:buNone/>
-            </a:pPr>
-            <a:r>
-              <a:rPr lang="en-US" sz="1150" dirty="0">
-                <a:solidFill>
-                  <a:srgbClr val="0F1419"/>
-                </a:solidFill>
-                <a:latin typeface="Arial" pitchFamily="34" charset="0"/>
-                <a:ea typeface="Arial" pitchFamily="34" charset="-122"/>
-                <a:cs typeface="Arial" pitchFamily="34" charset="-120"/>
-              </a:rPr>
-              <a:t>Telegram alerts on a real phone (being checked)</a:t>
-            </a:r>
-            <a:endParaRPr lang="en-US" sz="1150" dirty="0"/>
-          </a:p>
-        </p:txBody>
-      </p:sp>
-      <p:sp>
-        <p:nvSpPr>
-          <p:cNvPr id="35" name="Shape 19"/>
+      <p:sp>
+        <p:nvSpPr>
+          <p:cNvPr id="33" name="Shape 18"/>
           <p:cNvSpPr/>
           <p:nvPr/>
         </p:nvSpPr>
@@ -11843,7 +11759,7 @@
       </p:sp>
       <p:sp>
         <p:nvSpPr>
-          <p:cNvPr id="36" name="Text 20"/>
+          <p:cNvPr id="34" name="Text 19"/>
           <p:cNvSpPr txBox="1"/>
           <p:nvPr/>
         </p:nvSpPr>
@@ -11882,7 +11798,7 @@
       </p:sp>
       <p:sp>
         <p:nvSpPr>
-          <p:cNvPr id="37" name="Text 21"/>
+          <p:cNvPr id="35" name="Text 20"/>
           <p:cNvSpPr txBox="1"/>
           <p:nvPr/>
         </p:nvSpPr>
@@ -11921,7 +11837,7 @@
       </p:sp>
       <p:sp>
         <p:nvSpPr>
-          <p:cNvPr id="38" name="Text 22"/>
+          <p:cNvPr id="36" name="Text 21"/>
           <p:cNvSpPr txBox="1"/>
           <p:nvPr/>
         </p:nvSpPr>

</xml_diff>

<commit_message>
docs: the whole pitch story ran on devnet; the video is next; speed experiments for the laptop
- README, deck (rebuilt .pptx and PDF) and judge Q&A: the rehearsal take on
  devnet (20261003-1050, WS1 status) is done; the demo video, and the owner
  approving in the web app with a real wallet, are in progress.
- Message 20261003-1300 to the laptop: what changed for speed, two
  experiments (a higher priority fee, and reading the facilitator's settle
  times), Helius' free plan for an RPC that allows getProgramAccounts, and
  the agent's name settled without an on-chain change.
- BOARD and WS2 status follow.

Co-Authored-By: Claude Opus 5.5 <noreply@anthropic.com>
Claude-Session: https://claude.ai/code/session_01HymyG6fb24cdptwyaurt2h
</commit_message>
<xml_diff>
--- a/docs/pitch/leash-deck.pptx
+++ b/docs/pitch/leash-deck.pptx
@@ -4331,7 +4331,7 @@
                 <a:ea typeface="Arial" pitchFamily="34" charset="-122"/>
                 <a:cs typeface="Arial" pitchFamily="34" charset="-120"/>
               </a:rPr>
-              <a:t>The demo on devnet, and its recording</a:t>
+              <a:t>The demo video, recorded on devnet</a:t>
             </a:r>
             <a:endParaRPr lang="en-US" sz="1150" dirty="0"/>
           </a:p>
@@ -11254,7 +11254,7 @@
                 <a:ea typeface="Arial" pitchFamily="34" charset="-122"/>
                 <a:cs typeface="Arial" pitchFamily="34" charset="-120"/>
               </a:rPr>
-              <a:t>The whole story: on a local validator, in CI, and in one command</a:t>
+              <a:t>The whole story: on devnet, in CI, and in one command</a:t>
             </a:r>
             <a:endParaRPr lang="en-US" sz="1150" dirty="0"/>
           </a:p>
@@ -11693,7 +11693,7 @@
         <p:spPr>
           <a:xfrm>
             <a:off x="5961888" y="1481328"/>
-            <a:ext cx="2606040" cy="384048"/>
+            <a:ext cx="2606040" cy="201168"/>
           </a:xfrm>
           <a:prstGeom prst="rect">
             <a:avLst/>
@@ -11717,7 +11717,7 @@
                 <a:ea typeface="Arial" pitchFamily="34" charset="-122"/>
                 <a:cs typeface="Arial" pitchFamily="34" charset="-120"/>
               </a:rPr>
-              <a:t>The full demo on devnet, and its recording</a:t>
+              <a:t>The demo video, recorded on devnet</a:t>
             </a:r>
             <a:endParaRPr lang="en-US" sz="1150" dirty="0"/>
           </a:p>

</xml_diff>

<commit_message>
docs: test counts after today's work: 985 (857 TypeScript, 128 Rust), 15 browser tests
Counted from `pnpm check` on this branch (sdk 261, contracts 178, web 117,
sentinel 102, indexer 57, agent-demo 40, tools 30, merchant-demo 24, x402 23,
mcp 10, facilitator 9, e2e 6) and the WS1 status for Rust (unchanged since
2026-09-30). The web app has 15 Playwright tests (7 on sample data, 8 live on
LiteSVM). README, deck (rebuilt .pptx and PDF), judge Q&A and BOARD.

Co-Authored-By: Claude Opus 5.5 <noreply@anthropic.com>
Claude-Session: https://claude.ai/code/session_01HymyG6fb24cdptwyaurt2h
</commit_message>
<xml_diff>
--- a/docs/pitch/leash-deck.pptx
+++ b/docs/pitch/leash-deck.pptx
@@ -11790,7 +11790,7 @@
                 <a:ea typeface="Arial" pitchFamily="34" charset="-122"/>
                 <a:cs typeface="Arial" pitchFamily="34" charset="-120"/>
               </a:rPr>
-              <a:t>964</a:t>
+              <a:t>985</a:t>
             </a:r>
             <a:endParaRPr lang="en-US" sz="3600" dirty="0"/>
           </a:p>
@@ -11868,7 +11868,7 @@
                 <a:ea typeface="Arial" pitchFamily="34" charset="-122"/>
                 <a:cs typeface="Arial" pitchFamily="34" charset="-120"/>
               </a:rPr>
-              <a:t>836 TypeScript · 128 Rust</a:t>
+              <a:t>857 TypeScript · 128 Rust</a:t>
             </a:r>
             <a:endParaRPr lang="en-US" sz="1000" dirty="0"/>
           </a:p>

</xml_diff>

<commit_message>
docs: the team is Parth Deshmukh, solo builder
Parth answered the open question: he built Leash alone. The README's Team
section, deck slides 1 and 13 (plain text now, no amber placeholder chip;
.pptx and PDF rebuilt) and the judge Q&A say so, alongside the existing note
that the code came from Claude Code sessions he planned and steered. No team
placeholders are left.

Co-Authored-By: Claude Opus 5.5 <noreply@anthropic.com>
Claude-Session: https://claude.ai/code/session_01HymyG6fb24cdptwyaurt2h
</commit_message>
<xml_diff>
--- a/docs/pitch/leash-deck.pptx
+++ b/docs/pitch/leash-deck.pptx
@@ -2141,68 +2141,46 @@
       </p:sp>
       <p:sp>
         <p:nvSpPr>
-          <p:cNvPr id="7" name="Shape 5"/>
-          <p:cNvSpPr/>
+          <p:cNvPr id="7" name="Text 5"/>
+          <p:cNvSpPr txBox="1"/>
           <p:nvPr/>
         </p:nvSpPr>
         <p:spPr>
           <a:xfrm>
             <a:off x="548640" y="4160520"/>
-            <a:ext cx="3931920" cy="329184"/>
-          </a:xfrm>
-          <a:prstGeom prst="roundRect">
-            <a:avLst>
-              <a:gd name="adj" fmla="val 277778"/>
-            </a:avLst>
-          </a:prstGeom>
-          <a:solidFill>
-            <a:srgbClr val="F8EEE6"/>
-          </a:solidFill>
-          <a:ln/>
-        </p:spPr>
-      </p:sp>
-      <p:sp>
-        <p:nvSpPr>
-          <p:cNvPr id="8" name="Text 6"/>
-          <p:cNvSpPr txBox="1"/>
-          <p:nvPr/>
-        </p:nvSpPr>
-        <p:spPr>
-          <a:xfrm>
-            <a:off x="548640" y="4160520"/>
-            <a:ext cx="3931920" cy="329184"/>
-          </a:xfrm>
-          <a:prstGeom prst="rect">
-            <a:avLst/>
-          </a:prstGeom>
-          <a:noFill/>
-          <a:ln/>
-        </p:spPr>
-        <p:txBody>
-          <a:bodyPr wrap="square" lIns="0" tIns="0" rIns="0" bIns="0" rtlCol="0" anchor="ctr"/>
-          <a:lstStyle/>
-          <a:p>
-            <a:pPr algn="ctr" indent="0" marL="0">
-              <a:buNone/>
-            </a:pPr>
-            <a:r>
-              <a:rPr lang="en-US" sz="1000" b="1" dirty="0">
-                <a:solidFill>
-                  <a:srgbClr val="B45309"/>
-                </a:solidFill>
-                <a:latin typeface="Arial" pitchFamily="34" charset="0"/>
-                <a:ea typeface="Arial" pitchFamily="34" charset="-122"/>
-                <a:cs typeface="Arial" pitchFamily="34" charset="-120"/>
-              </a:rPr>
-              <a:t>[Team: names and roles, to be filled in by Parth]</a:t>
-            </a:r>
-            <a:endParaRPr lang="en-US" sz="1000" dirty="0"/>
+            <a:ext cx="4114800" cy="274320"/>
+          </a:xfrm>
+          <a:prstGeom prst="rect">
+            <a:avLst/>
+          </a:prstGeom>
+          <a:noFill/>
+          <a:ln/>
+        </p:spPr>
+        <p:txBody>
+          <a:bodyPr wrap="square" lIns="0" tIns="0" rIns="0" bIns="0" rtlCol="0" anchor="t"/>
+          <a:lstStyle/>
+          <a:p>
+            <a:pPr algn="l" indent="0" marL="0">
+              <a:buNone/>
+            </a:pPr>
+            <a:r>
+              <a:rPr lang="en-US" sz="1100" b="1" dirty="0">
+                <a:solidFill>
+                  <a:srgbClr val="0F1419"/>
+                </a:solidFill>
+                <a:latin typeface="Arial" pitchFamily="34" charset="0"/>
+                <a:ea typeface="Arial" pitchFamily="34" charset="-122"/>
+                <a:cs typeface="Arial" pitchFamily="34" charset="-120"/>
+              </a:rPr>
+              <a:t>Parth Deshmukh · solo builder</a:t>
+            </a:r>
+            <a:endParaRPr lang="en-US" sz="1100" dirty="0"/>
           </a:p>
         </p:txBody>
       </p:sp>
       <p:pic>
         <p:nvPicPr>
-          <p:cNvPr id="9" name="Image 0" descr="preencoded.png">    </p:cNvPr>
+          <p:cNvPr id="8" name="Image 0" descr="preencoded.png">    </p:cNvPr>
           <p:cNvPicPr>
             <a:picLocks noChangeAspect="1"/>
           </p:cNvPicPr>
@@ -2226,7 +2204,7 @@
       </p:pic>
       <p:sp>
         <p:nvSpPr>
-          <p:cNvPr id="10" name="Shape 7"/>
+          <p:cNvPr id="9" name="Shape 6"/>
           <p:cNvSpPr/>
           <p:nvPr/>
         </p:nvSpPr>
@@ -2253,7 +2231,7 @@
       </p:sp>
       <p:sp>
         <p:nvSpPr>
-          <p:cNvPr id="11" name="Text 8"/>
+          <p:cNvPr id="10" name="Text 7"/>
           <p:cNvSpPr txBox="1"/>
           <p:nvPr/>
         </p:nvSpPr>
@@ -4914,68 +4892,46 @@
       </p:sp>
       <p:sp>
         <p:nvSpPr>
-          <p:cNvPr id="6" name="Shape 4"/>
-          <p:cNvSpPr/>
+          <p:cNvPr id="6" name="Text 4"/>
+          <p:cNvSpPr txBox="1"/>
           <p:nvPr/>
         </p:nvSpPr>
         <p:spPr>
           <a:xfrm>
             <a:off x="2514600" y="3017520"/>
-            <a:ext cx="4114800" cy="329184"/>
-          </a:xfrm>
-          <a:prstGeom prst="roundRect">
-            <a:avLst>
-              <a:gd name="adj" fmla="val 277778"/>
-            </a:avLst>
-          </a:prstGeom>
-          <a:solidFill>
-            <a:srgbClr val="F8EEE6"/>
-          </a:solidFill>
-          <a:ln/>
-        </p:spPr>
-      </p:sp>
-      <p:sp>
-        <p:nvSpPr>
-          <p:cNvPr id="7" name="Text 5"/>
-          <p:cNvSpPr txBox="1"/>
-          <p:nvPr/>
-        </p:nvSpPr>
-        <p:spPr>
-          <a:xfrm>
-            <a:off x="2514600" y="3017520"/>
-            <a:ext cx="4114800" cy="329184"/>
-          </a:xfrm>
-          <a:prstGeom prst="rect">
-            <a:avLst/>
-          </a:prstGeom>
-          <a:noFill/>
-          <a:ln/>
-        </p:spPr>
-        <p:txBody>
-          <a:bodyPr wrap="square" lIns="0" tIns="0" rIns="0" bIns="0" rtlCol="0" anchor="ctr"/>
+            <a:ext cx="4114800" cy="274320"/>
+          </a:xfrm>
+          <a:prstGeom prst="rect">
+            <a:avLst/>
+          </a:prstGeom>
+          <a:noFill/>
+          <a:ln/>
+        </p:spPr>
+        <p:txBody>
+          <a:bodyPr wrap="square" lIns="0" tIns="0" rIns="0" bIns="0" rtlCol="0" anchor="t"/>
           <a:lstStyle/>
           <a:p>
             <a:pPr algn="ctr" indent="0" marL="0">
               <a:buNone/>
             </a:pPr>
             <a:r>
-              <a:rPr lang="en-US" sz="1000" b="1" dirty="0">
-                <a:solidFill>
-                  <a:srgbClr val="B45309"/>
-                </a:solidFill>
-                <a:latin typeface="Arial" pitchFamily="34" charset="0"/>
-                <a:ea typeface="Arial" pitchFamily="34" charset="-122"/>
-                <a:cs typeface="Arial" pitchFamily="34" charset="-120"/>
-              </a:rPr>
-              <a:t>[Team: names and roles, to be filled in by Parth]</a:t>
-            </a:r>
-            <a:endParaRPr lang="en-US" sz="1000" dirty="0"/>
+              <a:rPr lang="en-US" sz="1200" b="1" dirty="0">
+                <a:solidFill>
+                  <a:srgbClr val="0F1419"/>
+                </a:solidFill>
+                <a:latin typeface="Arial" pitchFamily="34" charset="0"/>
+                <a:ea typeface="Arial" pitchFamily="34" charset="-122"/>
+                <a:cs typeface="Arial" pitchFamily="34" charset="-120"/>
+              </a:rPr>
+              <a:t>Parth Deshmukh · solo builder</a:t>
+            </a:r>
+            <a:endParaRPr lang="en-US" sz="1200" dirty="0"/>
           </a:p>
         </p:txBody>
       </p:sp>
       <p:pic>
         <p:nvPicPr>
-          <p:cNvPr id="8" name="Image 0" descr="preencoded.png">    </p:cNvPr>
+          <p:cNvPr id="7" name="Image 0" descr="preencoded.png">    </p:cNvPr>
           <p:cNvPicPr>
             <a:picLocks noChangeAspect="1"/>
           </p:cNvPicPr>
@@ -4999,7 +4955,7 @@
       </p:pic>
       <p:sp>
         <p:nvSpPr>
-          <p:cNvPr id="9" name="Text 6"/>
+          <p:cNvPr id="8" name="Text 5"/>
           <p:cNvSpPr txBox="1"/>
           <p:nvPr/>
         </p:nvSpPr>
@@ -5045,7 +5001,7 @@
       </p:sp>
       <p:pic>
         <p:nvPicPr>
-          <p:cNvPr id="10" name="Image 1" descr="preencoded.png">    </p:cNvPr>
+          <p:cNvPr id="9" name="Image 1" descr="preencoded.png">    </p:cNvPr>
           <p:cNvPicPr>
             <a:picLocks noChangeAspect="1"/>
           </p:cNvPicPr>
@@ -5069,7 +5025,7 @@
       </p:pic>
       <p:sp>
         <p:nvSpPr>
-          <p:cNvPr id="11" name="Text 7"/>
+          <p:cNvPr id="10" name="Text 6"/>
           <p:cNvSpPr txBox="1"/>
           <p:nvPr/>
         </p:nvSpPr>
@@ -5115,7 +5071,7 @@
       </p:sp>
       <p:pic>
         <p:nvPicPr>
-          <p:cNvPr id="12" name="Image 2" descr="preencoded.png">    </p:cNvPr>
+          <p:cNvPr id="11" name="Image 2" descr="preencoded.png">    </p:cNvPr>
           <p:cNvPicPr>
             <a:picLocks noChangeAspect="1"/>
           </p:cNvPicPr>
@@ -5139,7 +5095,7 @@
       </p:pic>
       <p:sp>
         <p:nvSpPr>
-          <p:cNvPr id="13" name="Text 8"/>
+          <p:cNvPr id="12" name="Text 7"/>
           <p:cNvSpPr txBox="1"/>
           <p:nvPr/>
         </p:nvSpPr>
@@ -5178,7 +5134,7 @@
       </p:sp>
       <p:sp>
         <p:nvSpPr>
-          <p:cNvPr id="14" name="Text 9"/>
+          <p:cNvPr id="13" name="Text 8"/>
           <p:cNvSpPr txBox="1"/>
           <p:nvPr/>
         </p:nvSpPr>

</xml_diff>

<commit_message>
docs: the demo video is recorded (link to follow), described as it is
The laptop's report (20261003-1145): a 1:51 narrated video that replays the
second devnet take of the storyline line by line at its real timing, with two
on-chain cards read from devnet and labelled sample-data shots of the control
panel. The owner approved from the terminal, so:
- README: the video row says what the video shows; the control panel row no
  longer promises a real-wallet approval in it.
- Deck (rebuilt .pptx and PDF) and judge Q&A: "in progress" is now the control
  panel with a real wallet on devnet; the storyline ran on devnet twice.
- BOARD and WS2 status follow. The link goes in once Parth uploads the video.

Co-Authored-By: Claude Opus 5.5 <noreply@anthropic.com>
Claude-Session: https://claude.ai/code/session_01HymyG6fb24cdptwyaurt2h
</commit_message>
<xml_diff>
--- a/docs/pitch/leash-deck.pptx
+++ b/docs/pitch/leash-deck.pptx
@@ -4309,27 +4309,6 @@
                 <a:ea typeface="Arial" pitchFamily="34" charset="-122"/>
                 <a:cs typeface="Arial" pitchFamily="34" charset="-120"/>
               </a:rPr>
-              <a:t>The demo video, recorded on devnet</a:t>
-            </a:r>
-            <a:endParaRPr lang="en-US" sz="1150" dirty="0"/>
-          </a:p>
-          <a:p>
-            <a:pPr marL="177800" indent="-177800">
-              <a:spcAft>
-                <a:spcPts val="600"/>
-              </a:spcAft>
-              <a:buSzPct val="100000"/>
-              <a:buChar char="•"/>
-            </a:pPr>
-            <a:r>
-              <a:rPr lang="en-US" sz="1150" dirty="0">
-                <a:solidFill>
-                  <a:srgbClr val="0F1419"/>
-                </a:solidFill>
-                <a:latin typeface="Arial" pitchFamily="34" charset="0"/>
-                <a:ea typeface="Arial" pitchFamily="34" charset="-122"/>
-                <a:cs typeface="Arial" pitchFamily="34" charset="-120"/>
-              </a:rPr>
               <a:t>The web app with a real wallet on devnet</a:t>
             </a:r>
             <a:endParaRPr lang="en-US" sz="1150" dirty="0"/>
@@ -11649,7 +11628,7 @@
         <p:spPr>
           <a:xfrm>
             <a:off x="5961888" y="1481328"/>
-            <a:ext cx="2606040" cy="201168"/>
+            <a:ext cx="2606040" cy="384048"/>
           </a:xfrm>
           <a:prstGeom prst="rect">
             <a:avLst/>
@@ -11673,7 +11652,7 @@
                 <a:ea typeface="Arial" pitchFamily="34" charset="-122"/>
                 <a:cs typeface="Arial" pitchFamily="34" charset="-120"/>
               </a:rPr>
-              <a:t>The demo video, recorded on devnet</a:t>
+              <a:t>The control panel with a real wallet, on devnet</a:t>
             </a:r>
             <a:endParaRPr lang="en-US" sz="1150" dirty="0"/>
           </a:p>

</xml_diff>

<commit_message>
docs: link the demo video from the deck, the judge Q&A and the board
The laptop put the narrated video in the repo (docs/pitch/leash-demo-devnet.mp4,
2:19, 10.4 MB) and linked it from the README. Slide 13 now links it (.pptx and
PDF rebuilt), deck.md and the judge Q&A point to it, and the BOARD shows the
WS9 pass and laptop queue item 7 as done.

Co-Authored-By: Claude Opus 5.5 <noreply@anthropic.com>
Claude-Session: https://claude.ai/code/session_01HymyG6fb24cdptwyaurt2h
</commit_message>
<xml_diff>
--- a/docs/pitch/leash-deck.pptx
+++ b/docs/pitch/leash-deck.pptx
@@ -5097,15 +5097,22 @@
               <a:buNone/>
             </a:pPr>
             <a:r>
-              <a:rPr lang="en-US" sz="950" dirty="0">
-                <a:solidFill>
-                  <a:srgbClr val="0F1419"/>
-                </a:solidFill>
-                <a:latin typeface="Arial" pitchFamily="34" charset="0"/>
-                <a:ea typeface="Arial" pitchFamily="34" charset="-122"/>
-                <a:cs typeface="Arial" pitchFamily="34" charset="-120"/>
-              </a:rPr>
-              <a:t>Demo video: in progress</a:t>
+              <a:rPr lang="en-US" sz="950" u="sng" dirty="0">
+                <a:solidFill>
+                  <a:srgbClr val="6D28D9"/>
+                </a:solidFill>
+                <a:latin typeface="Arial" pitchFamily="34" charset="0"/>
+                <a:ea typeface="Arial" pitchFamily="34" charset="-122"/>
+                <a:cs typeface="Arial" pitchFamily="34" charset="-120"/>
+                <a:hlinkClick r:id="rId6" invalidUrl="" action="" tgtFrame="" tooltip="" history="1" highlightClick="0" endSnd="0">
+                  <a:extLst>
+                    <a:ext uri="{A12FA001-AC4F-418D-AE19-62706E023703}">
+                      <ahyp:hlinkClr xmlns:ahyp="http://schemas.microsoft.com/office/drawing/2018/hyperlinkcolor" val="tx"/>
+                    </a:ext>
+                  </a:extLst>
+                </a:hlinkClick>
+              </a:rPr>
+              <a:t>Demo video (2:19)</a:t>
             </a:r>
             <a:endParaRPr lang="en-US" sz="950" dirty="0"/>
           </a:p>

</xml_diff>

<commit_message>
docs: describe the build as parallel workstreams; drop the tool credit from the README, deck and Q&A
</commit_message>
<xml_diff>
--- a/docs/pitch/leash-deck.pptx
+++ b/docs/pitch/leash-deck.pptx
@@ -5174,45 +5174,6 @@
           </a:p>
         </p:txBody>
       </p:sp>
-      <p:sp>
-        <p:nvSpPr>
-          <p:cNvPr id="13" name="Text 8"/>
-          <p:cNvSpPr txBox="1"/>
-          <p:nvPr/>
-        </p:nvSpPr>
-        <p:spPr>
-          <a:xfrm>
-            <a:off x="548640" y="4434840"/>
-            <a:ext cx="8046720" cy="228600"/>
-          </a:xfrm>
-          <a:prstGeom prst="rect">
-            <a:avLst/>
-          </a:prstGeom>
-          <a:noFill/>
-          <a:ln/>
-        </p:spPr>
-        <p:txBody>
-          <a:bodyPr wrap="square" lIns="0" tIns="0" rIns="0" bIns="0" rtlCol="0" anchor="t"/>
-          <a:lstStyle/>
-          <a:p>
-            <a:pPr algn="ctr" indent="0" marL="0">
-              <a:buNone/>
-            </a:pPr>
-            <a:r>
-              <a:rPr lang="en-US" sz="900" dirty="0">
-                <a:solidFill>
-                  <a:srgbClr val="535C6B"/>
-                </a:solidFill>
-                <a:latin typeface="Arial" pitchFamily="34" charset="0"/>
-                <a:ea typeface="Arial" pitchFamily="34" charset="-122"/>
-                <a:cs typeface="Arial" pitchFamily="34" charset="-120"/>
-              </a:rPr>
-              <a:t>Built with parallel Claude Code sessions, each owning one part of the architecture.</a:t>
-            </a:r>
-            <a:endParaRPr lang="en-US" sz="900" dirty="0"/>
-          </a:p>
-        </p:txBody>
-      </p:sp>
     </p:spTree>
   </p:cSld>
   <p:clrMapOvr>

</xml_diff>